<commit_message>
docs: add compiled manuscript PDF and fix slide 6 labels
- Add Overleaf-compiled manuscript PDF (reports/ieee_report/phase1_final_manuscript.pdf)
- Fix slide 6 pipeline labels, which wrapped one letter per line in PowerPoint
- Use unrounded values in slide charts so labels match the paper (XGBoost AP 0.349)
- Move Fig. 1 legend above the plot so it no longer overlaps bars

Co-Authored-By: Claude Opus 5.5 <noreply@anthropic.com>
</commit_message>
<xml_diff>
--- a/reports/presentation/phase1_final_presentation.pptx
+++ b/reports/presentation/phase1_final_presentation.pptx
@@ -442,13 +442,13 @@
                 <c:formatCode>General</c:formatCode>
                 <c:ptCount val="3"/>
                 <c:pt idx="0">
-                  <c:v>0.6987</c:v>
+                  <c:v>0.6986974288127379</c:v>
                 </c:pt>
                 <c:pt idx="1">
-                  <c:v>0.7208</c:v>
+                  <c:v>0.7207928648528075</c:v>
                 </c:pt>
                 <c:pt idx="2">
-                  <c:v>0.7114</c:v>
+                  <c:v>0.711399356098784</c:v>
                 </c:pt>
               </c:numCache>
             </c:numRef>
@@ -497,13 +497,13 @@
                 <c:formatCode>General</c:formatCode>
                 <c:ptCount val="3"/>
                 <c:pt idx="0">
-                  <c:v>0.7203</c:v>
+                  <c:v>0.7203255241878851</c:v>
                 </c:pt>
                 <c:pt idx="1">
-                  <c:v>0.7215</c:v>
+                  <c:v>0.7215181452348028</c:v>
                 </c:pt>
                 <c:pt idx="2">
-                  <c:v>0.7024</c:v>
+                  <c:v>0.7023809811048615</c:v>
                 </c:pt>
               </c:numCache>
             </c:numRef>
@@ -552,13 +552,13 @@
                 <c:formatCode>General</c:formatCode>
                 <c:ptCount val="3"/>
                 <c:pt idx="0">
-                  <c:v>0.7138</c:v>
+                  <c:v>0.7138232790201909</c:v>
                 </c:pt>
                 <c:pt idx="1">
-                  <c:v>0.7488</c:v>
+                  <c:v>0.7487961050314101</c:v>
                 </c:pt>
                 <c:pt idx="2">
-                  <c:v>0.7456</c:v>
+                  <c:v>0.7456137265821804</c:v>
                 </c:pt>
               </c:numCache>
             </c:numRef>
@@ -772,13 +772,13 @@
                 <c:formatCode>General</c:formatCode>
                 <c:ptCount val="3"/>
                 <c:pt idx="0">
-                  <c:v>0.2602</c:v>
+                  <c:v>0.26019770150384397</c:v>
                 </c:pt>
                 <c:pt idx="1">
-                  <c:v>0.3458</c:v>
+                  <c:v>0.34578705475756033</c:v>
                 </c:pt>
                 <c:pt idx="2">
-                  <c:v>0.3027</c:v>
+                  <c:v>0.30269741838054776</c:v>
                 </c:pt>
               </c:numCache>
             </c:numRef>
@@ -827,13 +827,13 @@
                 <c:formatCode>General</c:formatCode>
                 <c:ptCount val="3"/>
                 <c:pt idx="0">
-                  <c:v>0.1968</c:v>
+                  <c:v>0.19678093810862504</c:v>
                 </c:pt>
                 <c:pt idx="1">
-                  <c:v>0.2901</c:v>
+                  <c:v>0.2900693960693849</c:v>
                 </c:pt>
                 <c:pt idx="2">
-                  <c:v>0.2911</c:v>
+                  <c:v>0.2911113954603743</c:v>
                 </c:pt>
               </c:numCache>
             </c:numRef>
@@ -882,13 +882,13 @@
                 <c:formatCode>General</c:formatCode>
                 <c:ptCount val="3"/>
                 <c:pt idx="0">
-                  <c:v>0.2341</c:v>
+                  <c:v>0.2341341765380798</c:v>
                 </c:pt>
                 <c:pt idx="1">
-                  <c:v>0.3891</c:v>
+                  <c:v>0.3890925932486169</c:v>
                 </c:pt>
                 <c:pt idx="2">
-                  <c:v>0.3495</c:v>
+                  <c:v>0.34949036805972095</c:v>
                 </c:pt>
               </c:numCache>
             </c:numRef>
@@ -14318,12 +14318,38 @@
           </a:fontRef>
         </p:style>
         <p:txBody>
-          <a:bodyPr rtlCol="0" anchor="ctr" lIns="274320" rIns="182880"/>
+          <a:bodyPr rtlCol="0" anchor="ctr"/>
           <a:lstStyle/>
           <a:p>
             <a:pPr algn="ctr"/>
-            <a:r>
-              <a:rPr sz="1300" b="1">
+          </a:p>
+        </p:txBody>
+      </p:sp>
+      <p:sp>
+        <p:nvSpPr>
+          <p:cNvPr id="5" name="TextBox 4"/>
+          <p:cNvSpPr txBox="1"/>
+          <p:nvPr/>
+        </p:nvSpPr>
+        <p:spPr>
+          <a:xfrm>
+            <a:off x="594360" y="1828800"/>
+            <a:ext cx="1143000" cy="960120"/>
+          </a:xfrm>
+          <a:prstGeom prst="rect">
+            <a:avLst/>
+          </a:prstGeom>
+          <a:noFill/>
+        </p:spPr>
+        <p:txBody>
+          <a:bodyPr wrap="square" anchor="ctr" lIns="0" rIns="0" tIns="0" bIns="0">
+            <a:spAutoFit/>
+          </a:bodyPr>
+          <a:lstStyle/>
+          <a:p>
+            <a:pPr algn="ctr"/>
+            <a:r>
+              <a:rPr sz="1300" b="1" i="0">
                 <a:solidFill>
                   <a:srgbClr val="FFFFFF"/>
                 </a:solidFill>
@@ -14336,7 +14362,7 @@
       </p:sp>
       <p:sp>
         <p:nvSpPr>
-          <p:cNvPr id="5" name="Rounded Rectangle 4"/>
+          <p:cNvPr id="6" name="Rounded Rectangle 5"/>
           <p:cNvSpPr/>
           <p:nvPr/>
         </p:nvSpPr>
@@ -14382,7 +14408,7 @@
       </p:sp>
       <p:sp>
         <p:nvSpPr>
-          <p:cNvPr id="6" name="TextBox 5"/>
+          <p:cNvPr id="7" name="TextBox 6"/>
           <p:cNvSpPr txBox="1"/>
           <p:nvPr/>
         </p:nvSpPr>
@@ -14418,7 +14444,7 @@
       </p:sp>
       <p:sp>
         <p:nvSpPr>
-          <p:cNvPr id="7" name="Chevron 6"/>
+          <p:cNvPr id="8" name="Chevron 7"/>
           <p:cNvSpPr/>
           <p:nvPr/>
         </p:nvSpPr>
@@ -14453,12 +14479,38 @@
           </a:fontRef>
         </p:style>
         <p:txBody>
-          <a:bodyPr rtlCol="0" anchor="ctr" lIns="274320" rIns="182880"/>
+          <a:bodyPr rtlCol="0" anchor="ctr"/>
           <a:lstStyle/>
           <a:p>
             <a:pPr algn="ctr"/>
-            <a:r>
-              <a:rPr sz="1300" b="1">
+          </a:p>
+        </p:txBody>
+      </p:sp>
+      <p:sp>
+        <p:nvSpPr>
+          <p:cNvPr id="9" name="TextBox 8"/>
+          <p:cNvSpPr txBox="1"/>
+          <p:nvPr/>
+        </p:nvSpPr>
+        <p:spPr>
+          <a:xfrm>
+            <a:off x="2423160" y="1828800"/>
+            <a:ext cx="960120" cy="960120"/>
+          </a:xfrm>
+          <a:prstGeom prst="rect">
+            <a:avLst/>
+          </a:prstGeom>
+          <a:noFill/>
+        </p:spPr>
+        <p:txBody>
+          <a:bodyPr wrap="square" anchor="ctr" lIns="0" rIns="0" tIns="0" bIns="0">
+            <a:spAutoFit/>
+          </a:bodyPr>
+          <a:lstStyle/>
+          <a:p>
+            <a:pPr algn="ctr"/>
+            <a:r>
+              <a:rPr sz="1300" b="1" i="0">
                 <a:solidFill>
                   <a:srgbClr val="FFFFFF"/>
                 </a:solidFill>
@@ -14471,7 +14523,7 @@
       </p:sp>
       <p:sp>
         <p:nvSpPr>
-          <p:cNvPr id="8" name="Rounded Rectangle 7"/>
+          <p:cNvPr id="10" name="Rounded Rectangle 9"/>
           <p:cNvSpPr/>
           <p:nvPr/>
         </p:nvSpPr>
@@ -14517,7 +14569,7 @@
       </p:sp>
       <p:sp>
         <p:nvSpPr>
-          <p:cNvPr id="9" name="TextBox 8"/>
+          <p:cNvPr id="11" name="TextBox 10"/>
           <p:cNvSpPr txBox="1"/>
           <p:nvPr/>
         </p:nvSpPr>
@@ -14554,7 +14606,7 @@
       </p:sp>
       <p:sp>
         <p:nvSpPr>
-          <p:cNvPr id="10" name="Chevron 9"/>
+          <p:cNvPr id="12" name="Chevron 11"/>
           <p:cNvSpPr/>
           <p:nvPr/>
         </p:nvSpPr>
@@ -14589,12 +14641,38 @@
           </a:fontRef>
         </p:style>
         <p:txBody>
-          <a:bodyPr rtlCol="0" anchor="ctr" lIns="274320" rIns="182880"/>
+          <a:bodyPr rtlCol="0" anchor="ctr"/>
           <a:lstStyle/>
           <a:p>
             <a:pPr algn="ctr"/>
-            <a:r>
-              <a:rPr sz="1300" b="1">
+          </a:p>
+        </p:txBody>
+      </p:sp>
+      <p:sp>
+        <p:nvSpPr>
+          <p:cNvPr id="13" name="TextBox 12"/>
+          <p:cNvSpPr txBox="1"/>
+          <p:nvPr/>
+        </p:nvSpPr>
+        <p:spPr>
+          <a:xfrm>
+            <a:off x="4023359" y="1828800"/>
+            <a:ext cx="960120" cy="960120"/>
+          </a:xfrm>
+          <a:prstGeom prst="rect">
+            <a:avLst/>
+          </a:prstGeom>
+          <a:noFill/>
+        </p:spPr>
+        <p:txBody>
+          <a:bodyPr wrap="square" anchor="ctr" lIns="0" rIns="0" tIns="0" bIns="0">
+            <a:spAutoFit/>
+          </a:bodyPr>
+          <a:lstStyle/>
+          <a:p>
+            <a:pPr algn="ctr"/>
+            <a:r>
+              <a:rPr sz="1300" b="1" i="0">
                 <a:solidFill>
                   <a:srgbClr val="FFFFFF"/>
                 </a:solidFill>
@@ -14607,7 +14685,7 @@
       </p:sp>
       <p:sp>
         <p:nvSpPr>
-          <p:cNvPr id="11" name="Rounded Rectangle 10"/>
+          <p:cNvPr id="14" name="Rounded Rectangle 13"/>
           <p:cNvSpPr/>
           <p:nvPr/>
         </p:nvSpPr>
@@ -14653,7 +14731,7 @@
       </p:sp>
       <p:sp>
         <p:nvSpPr>
-          <p:cNvPr id="12" name="TextBox 11"/>
+          <p:cNvPr id="15" name="TextBox 14"/>
           <p:cNvSpPr txBox="1"/>
           <p:nvPr/>
         </p:nvSpPr>
@@ -14690,7 +14768,7 @@
       </p:sp>
       <p:sp>
         <p:nvSpPr>
-          <p:cNvPr id="13" name="Chevron 12"/>
+          <p:cNvPr id="16" name="Chevron 15"/>
           <p:cNvSpPr/>
           <p:nvPr/>
         </p:nvSpPr>
@@ -14725,12 +14803,38 @@
           </a:fontRef>
         </p:style>
         <p:txBody>
-          <a:bodyPr rtlCol="0" anchor="ctr" lIns="274320" rIns="182880"/>
+          <a:bodyPr rtlCol="0" anchor="ctr"/>
           <a:lstStyle/>
           <a:p>
             <a:pPr algn="ctr"/>
-            <a:r>
-              <a:rPr sz="1300" b="1">
+          </a:p>
+        </p:txBody>
+      </p:sp>
+      <p:sp>
+        <p:nvSpPr>
+          <p:cNvPr id="17" name="TextBox 16"/>
+          <p:cNvSpPr txBox="1"/>
+          <p:nvPr/>
+        </p:nvSpPr>
+        <p:spPr>
+          <a:xfrm>
+            <a:off x="5623559" y="1828800"/>
+            <a:ext cx="960120" cy="960120"/>
+          </a:xfrm>
+          <a:prstGeom prst="rect">
+            <a:avLst/>
+          </a:prstGeom>
+          <a:noFill/>
+        </p:spPr>
+        <p:txBody>
+          <a:bodyPr wrap="square" anchor="ctr" lIns="0" rIns="0" tIns="0" bIns="0">
+            <a:spAutoFit/>
+          </a:bodyPr>
+          <a:lstStyle/>
+          <a:p>
+            <a:pPr algn="ctr"/>
+            <a:r>
+              <a:rPr sz="1300" b="1" i="0">
                 <a:solidFill>
                   <a:srgbClr val="FFFFFF"/>
                 </a:solidFill>
@@ -14743,7 +14847,7 @@
       </p:sp>
       <p:sp>
         <p:nvSpPr>
-          <p:cNvPr id="14" name="Rounded Rectangle 13"/>
+          <p:cNvPr id="18" name="Rounded Rectangle 17"/>
           <p:cNvSpPr/>
           <p:nvPr/>
         </p:nvSpPr>
@@ -14789,7 +14893,7 @@
       </p:sp>
       <p:sp>
         <p:nvSpPr>
-          <p:cNvPr id="15" name="TextBox 14"/>
+          <p:cNvPr id="19" name="TextBox 18"/>
           <p:cNvSpPr txBox="1"/>
           <p:nvPr/>
         </p:nvSpPr>
@@ -14825,7 +14929,7 @@
       </p:sp>
       <p:sp>
         <p:nvSpPr>
-          <p:cNvPr id="16" name="Chevron 15"/>
+          <p:cNvPr id="20" name="Chevron 19"/>
           <p:cNvSpPr/>
           <p:nvPr/>
         </p:nvSpPr>
@@ -14860,12 +14964,38 @@
           </a:fontRef>
         </p:style>
         <p:txBody>
-          <a:bodyPr rtlCol="0" anchor="ctr" lIns="274320" rIns="182880"/>
+          <a:bodyPr rtlCol="0" anchor="ctr"/>
           <a:lstStyle/>
           <a:p>
             <a:pPr algn="ctr"/>
-            <a:r>
-              <a:rPr sz="1300" b="1">
+          </a:p>
+        </p:txBody>
+      </p:sp>
+      <p:sp>
+        <p:nvSpPr>
+          <p:cNvPr id="21" name="TextBox 20"/>
+          <p:cNvSpPr txBox="1"/>
+          <p:nvPr/>
+        </p:nvSpPr>
+        <p:spPr>
+          <a:xfrm>
+            <a:off x="7223759" y="1828800"/>
+            <a:ext cx="960120" cy="960120"/>
+          </a:xfrm>
+          <a:prstGeom prst="rect">
+            <a:avLst/>
+          </a:prstGeom>
+          <a:noFill/>
+        </p:spPr>
+        <p:txBody>
+          <a:bodyPr wrap="square" anchor="ctr" lIns="0" rIns="0" tIns="0" bIns="0">
+            <a:spAutoFit/>
+          </a:bodyPr>
+          <a:lstStyle/>
+          <a:p>
+            <a:pPr algn="ctr"/>
+            <a:r>
+              <a:rPr sz="1300" b="1" i="0">
                 <a:solidFill>
                   <a:srgbClr val="FFFFFF"/>
                 </a:solidFill>
@@ -14878,7 +15008,7 @@
       </p:sp>
       <p:sp>
         <p:nvSpPr>
-          <p:cNvPr id="17" name="Rounded Rectangle 16"/>
+          <p:cNvPr id="22" name="Rounded Rectangle 21"/>
           <p:cNvSpPr/>
           <p:nvPr/>
         </p:nvSpPr>
@@ -14924,7 +15054,7 @@
       </p:sp>
       <p:sp>
         <p:nvSpPr>
-          <p:cNvPr id="18" name="TextBox 17"/>
+          <p:cNvPr id="23" name="TextBox 22"/>
           <p:cNvSpPr txBox="1"/>
           <p:nvPr/>
         </p:nvSpPr>
@@ -14961,7 +15091,7 @@
       </p:sp>
       <p:sp>
         <p:nvSpPr>
-          <p:cNvPr id="19" name="Chevron 18"/>
+          <p:cNvPr id="24" name="Chevron 23"/>
           <p:cNvSpPr/>
           <p:nvPr/>
         </p:nvSpPr>
@@ -14996,12 +15126,38 @@
           </a:fontRef>
         </p:style>
         <p:txBody>
-          <a:bodyPr rtlCol="0" anchor="ctr" lIns="274320" rIns="182880"/>
+          <a:bodyPr rtlCol="0" anchor="ctr"/>
           <a:lstStyle/>
           <a:p>
             <a:pPr algn="ctr"/>
-            <a:r>
-              <a:rPr sz="1300" b="1">
+          </a:p>
+        </p:txBody>
+      </p:sp>
+      <p:sp>
+        <p:nvSpPr>
+          <p:cNvPr id="25" name="TextBox 24"/>
+          <p:cNvSpPr txBox="1"/>
+          <p:nvPr/>
+        </p:nvSpPr>
+        <p:spPr>
+          <a:xfrm>
+            <a:off x="8823960" y="1828800"/>
+            <a:ext cx="960120" cy="960120"/>
+          </a:xfrm>
+          <a:prstGeom prst="rect">
+            <a:avLst/>
+          </a:prstGeom>
+          <a:noFill/>
+        </p:spPr>
+        <p:txBody>
+          <a:bodyPr wrap="square" anchor="ctr" lIns="0" rIns="0" tIns="0" bIns="0">
+            <a:spAutoFit/>
+          </a:bodyPr>
+          <a:lstStyle/>
+          <a:p>
+            <a:pPr algn="ctr"/>
+            <a:r>
+              <a:rPr sz="1300" b="1" i="0">
                 <a:solidFill>
                   <a:srgbClr val="FFFFFF"/>
                 </a:solidFill>
@@ -15014,7 +15170,7 @@
       </p:sp>
       <p:sp>
         <p:nvSpPr>
-          <p:cNvPr id="20" name="Rounded Rectangle 19"/>
+          <p:cNvPr id="26" name="Rounded Rectangle 25"/>
           <p:cNvSpPr/>
           <p:nvPr/>
         </p:nvSpPr>
@@ -15060,7 +15216,7 @@
       </p:sp>
       <p:sp>
         <p:nvSpPr>
-          <p:cNvPr id="21" name="TextBox 20"/>
+          <p:cNvPr id="27" name="TextBox 26"/>
           <p:cNvSpPr txBox="1"/>
           <p:nvPr/>
         </p:nvSpPr>
@@ -15096,7 +15252,7 @@
       </p:sp>
       <p:sp>
         <p:nvSpPr>
-          <p:cNvPr id="22" name="Chevron 21"/>
+          <p:cNvPr id="28" name="Chevron 27"/>
           <p:cNvSpPr/>
           <p:nvPr/>
         </p:nvSpPr>
@@ -15131,12 +15287,38 @@
           </a:fontRef>
         </p:style>
         <p:txBody>
-          <a:bodyPr rtlCol="0" anchor="ctr" lIns="274320" rIns="182880"/>
+          <a:bodyPr rtlCol="0" anchor="ctr"/>
           <a:lstStyle/>
           <a:p>
             <a:pPr algn="ctr"/>
-            <a:r>
-              <a:rPr sz="1300" b="1">
+          </a:p>
+        </p:txBody>
+      </p:sp>
+      <p:sp>
+        <p:nvSpPr>
+          <p:cNvPr id="29" name="TextBox 28"/>
+          <p:cNvSpPr txBox="1"/>
+          <p:nvPr/>
+        </p:nvSpPr>
+        <p:spPr>
+          <a:xfrm>
+            <a:off x="10424160" y="1828800"/>
+            <a:ext cx="960120" cy="960120"/>
+          </a:xfrm>
+          <a:prstGeom prst="rect">
+            <a:avLst/>
+          </a:prstGeom>
+          <a:noFill/>
+        </p:spPr>
+        <p:txBody>
+          <a:bodyPr wrap="square" anchor="ctr" lIns="0" rIns="0" tIns="0" bIns="0">
+            <a:spAutoFit/>
+          </a:bodyPr>
+          <a:lstStyle/>
+          <a:p>
+            <a:pPr algn="ctr"/>
+            <a:r>
+              <a:rPr sz="1300" b="1" i="0">
                 <a:solidFill>
                   <a:srgbClr val="FFFFFF"/>
                 </a:solidFill>
@@ -15149,7 +15331,7 @@
       </p:sp>
       <p:sp>
         <p:nvSpPr>
-          <p:cNvPr id="23" name="Rounded Rectangle 22"/>
+          <p:cNvPr id="30" name="Rounded Rectangle 29"/>
           <p:cNvSpPr/>
           <p:nvPr/>
         </p:nvSpPr>
@@ -15195,7 +15377,7 @@
       </p:sp>
       <p:sp>
         <p:nvSpPr>
-          <p:cNvPr id="24" name="TextBox 23"/>
+          <p:cNvPr id="31" name="TextBox 30"/>
           <p:cNvSpPr txBox="1"/>
           <p:nvPr/>
         </p:nvSpPr>
@@ -15231,7 +15413,7 @@
       </p:sp>
       <p:sp>
         <p:nvSpPr>
-          <p:cNvPr id="25" name="Rounded Rectangle 24"/>
+          <p:cNvPr id="32" name="Rounded Rectangle 31"/>
           <p:cNvSpPr/>
           <p:nvPr/>
         </p:nvSpPr>
@@ -15279,7 +15461,7 @@
       </p:sp>
       <p:sp>
         <p:nvSpPr>
-          <p:cNvPr id="26" name="TextBox 25"/>
+          <p:cNvPr id="33" name="TextBox 32"/>
           <p:cNvSpPr txBox="1"/>
           <p:nvPr/>
         </p:nvSpPr>

</xml_diff>

<commit_message>
docs: add BTech Computer Science & AI, Newton School of Technology to manuscript and presentation deck
</commit_message>
<xml_diff>
--- a/reports/presentation/phase1_final_presentation.pptx
+++ b/reports/presentation/phase1_final_presentation.pptx
@@ -5060,7 +5060,7 @@
         </p:nvSpPr>
         <p:spPr>
           <a:xfrm>
-            <a:off x="731520" y="731520"/>
+            <a:off x="731520" y="548640"/>
             <a:ext cx="10698480" cy="365760"/>
           </a:xfrm>
           <a:prstGeom prst="rect">
@@ -5095,8 +5095,8 @@
         </p:nvSpPr>
         <p:spPr>
           <a:xfrm>
-            <a:off x="731520" y="1188720"/>
-            <a:ext cx="10698480" cy="1828800"/>
+            <a:off x="731520" y="960120"/>
+            <a:ext cx="10698480" cy="1645920"/>
           </a:xfrm>
           <a:prstGeom prst="rect">
             <a:avLst/>
@@ -5111,7 +5111,7 @@
           <a:p>
             <a:pPr algn="l"/>
             <a:r>
-              <a:rPr sz="3600" b="1" i="0">
+              <a:rPr sz="3400" b="1" i="0">
                 <a:solidFill>
                   <a:srgbClr val="FFFFFF"/>
                 </a:solidFill>
@@ -5130,8 +5130,8 @@
         </p:nvSpPr>
         <p:spPr>
           <a:xfrm>
-            <a:off x="731520" y="3108960"/>
-            <a:ext cx="10698480" cy="457200"/>
+            <a:off x="731520" y="2651760"/>
+            <a:ext cx="10698480" cy="411480"/>
           </a:xfrm>
           <a:prstGeom prst="rect">
             <a:avLst/>
@@ -5146,7 +5146,7 @@
           <a:p>
             <a:pPr algn="l"/>
             <a:r>
-              <a:rPr sz="1800" b="0" i="1">
+              <a:rPr sz="1700" b="0" i="1">
                 <a:solidFill>
                   <a:srgbClr val="CAD5E2"/>
                 </a:solidFill>
@@ -5159,14 +5159,49 @@
       </p:sp>
       <p:sp>
         <p:nvSpPr>
-          <p:cNvPr id="5" name="Rounded Rectangle 4"/>
+          <p:cNvPr id="5" name="TextBox 4"/>
+          <p:cNvSpPr txBox="1"/>
+          <p:nvPr/>
+        </p:nvSpPr>
+        <p:spPr>
+          <a:xfrm>
+            <a:off x="731520" y="3154680"/>
+            <a:ext cx="10698480" cy="411480"/>
+          </a:xfrm>
+          <a:prstGeom prst="rect">
+            <a:avLst/>
+          </a:prstGeom>
+          <a:noFill/>
+        </p:spPr>
+        <p:txBody>
+          <a:bodyPr wrap="square" anchor="t" lIns="45720" rIns="45720">
+            <a:spAutoFit/>
+          </a:bodyPr>
+          <a:lstStyle/>
+          <a:p>
+            <a:pPr algn="l"/>
+            <a:r>
+              <a:rPr sz="1500" b="1" i="0">
+                <a:solidFill>
+                  <a:srgbClr val="8FD3BE"/>
+                </a:solidFill>
+                <a:latin typeface="Calibri"/>
+              </a:rPr>
+              <a:t>B.Tech Computer Science and AI  ·  Newton School of Technology</a:t>
+            </a:r>
+          </a:p>
+        </p:txBody>
+      </p:sp>
+      <p:sp>
+        <p:nvSpPr>
+          <p:cNvPr id="6" name="Rounded Rectangle 5"/>
           <p:cNvSpPr/>
           <p:nvPr/>
         </p:nvSpPr>
         <p:spPr>
           <a:xfrm>
-            <a:off x="731520" y="3931920"/>
-            <a:ext cx="2057400" cy="2194560"/>
+            <a:off x="731520" y="3794760"/>
+            <a:ext cx="2057400" cy="2331720"/>
           </a:xfrm>
           <a:prstGeom prst="roundRect">
             <a:avLst>
@@ -5207,13 +5242,13 @@
       </p:sp>
       <p:sp>
         <p:nvSpPr>
-          <p:cNvPr id="6" name="TextBox 5"/>
+          <p:cNvPr id="7" name="TextBox 6"/>
           <p:cNvSpPr txBox="1"/>
           <p:nvPr/>
         </p:nvSpPr>
         <p:spPr>
           <a:xfrm>
-            <a:off x="822960" y="4069080"/>
+            <a:off x="822960" y="3931920"/>
             <a:ext cx="1874519" cy="320040"/>
           </a:xfrm>
           <a:prstGeom prst="rect">
@@ -5242,13 +5277,13 @@
       </p:sp>
       <p:sp>
         <p:nvSpPr>
-          <p:cNvPr id="7" name="TextBox 6"/>
+          <p:cNvPr id="8" name="TextBox 7"/>
           <p:cNvSpPr txBox="1"/>
           <p:nvPr/>
         </p:nvSpPr>
         <p:spPr>
           <a:xfrm>
-            <a:off x="822960" y="4434840"/>
+            <a:off x="822960" y="4297680"/>
             <a:ext cx="1874519" cy="411480"/>
           </a:xfrm>
           <a:prstGeom prst="rect">
@@ -5277,14 +5312,14 @@
       </p:sp>
       <p:sp>
         <p:nvSpPr>
-          <p:cNvPr id="8" name="TextBox 7"/>
+          <p:cNvPr id="9" name="TextBox 8"/>
           <p:cNvSpPr txBox="1"/>
           <p:nvPr/>
         </p:nvSpPr>
         <p:spPr>
           <a:xfrm>
-            <a:off x="822960" y="4937760"/>
-            <a:ext cx="1874519" cy="1005840"/>
+            <a:off x="822960" y="4800600"/>
+            <a:ext cx="1874519" cy="1143000"/>
           </a:xfrm>
           <a:prstGeom prst="rect">
             <a:avLst/>
@@ -5313,14 +5348,14 @@
       </p:sp>
       <p:sp>
         <p:nvSpPr>
-          <p:cNvPr id="9" name="Rounded Rectangle 8"/>
+          <p:cNvPr id="10" name="Rounded Rectangle 9"/>
           <p:cNvSpPr/>
           <p:nvPr/>
         </p:nvSpPr>
         <p:spPr>
           <a:xfrm>
-            <a:off x="2907791" y="3931920"/>
-            <a:ext cx="2057400" cy="2194560"/>
+            <a:off x="2907791" y="3794760"/>
+            <a:ext cx="2057400" cy="2331720"/>
           </a:xfrm>
           <a:prstGeom prst="roundRect">
             <a:avLst>
@@ -5361,13 +5396,13 @@
       </p:sp>
       <p:sp>
         <p:nvSpPr>
-          <p:cNvPr id="10" name="TextBox 9"/>
+          <p:cNvPr id="11" name="TextBox 10"/>
           <p:cNvSpPr txBox="1"/>
           <p:nvPr/>
         </p:nvSpPr>
         <p:spPr>
           <a:xfrm>
-            <a:off x="2999232" y="4069080"/>
+            <a:off x="2999232" y="3931920"/>
             <a:ext cx="1874519" cy="320040"/>
           </a:xfrm>
           <a:prstGeom prst="rect">
@@ -5396,13 +5431,13 @@
       </p:sp>
       <p:sp>
         <p:nvSpPr>
-          <p:cNvPr id="11" name="TextBox 10"/>
+          <p:cNvPr id="12" name="TextBox 11"/>
           <p:cNvSpPr txBox="1"/>
           <p:nvPr/>
         </p:nvSpPr>
         <p:spPr>
           <a:xfrm>
-            <a:off x="2999232" y="4434840"/>
+            <a:off x="2999232" y="4297680"/>
             <a:ext cx="1874519" cy="411480"/>
           </a:xfrm>
           <a:prstGeom prst="rect">
@@ -5431,14 +5466,14 @@
       </p:sp>
       <p:sp>
         <p:nvSpPr>
-          <p:cNvPr id="12" name="TextBox 11"/>
+          <p:cNvPr id="13" name="TextBox 12"/>
           <p:cNvSpPr txBox="1"/>
           <p:nvPr/>
         </p:nvSpPr>
         <p:spPr>
           <a:xfrm>
-            <a:off x="2999232" y="4937760"/>
-            <a:ext cx="1874519" cy="1005840"/>
+            <a:off x="2999232" y="4800600"/>
+            <a:ext cx="1874519" cy="1143000"/>
           </a:xfrm>
           <a:prstGeom prst="rect">
             <a:avLst/>
@@ -5467,14 +5502,14 @@
       </p:sp>
       <p:sp>
         <p:nvSpPr>
-          <p:cNvPr id="13" name="Rounded Rectangle 12"/>
+          <p:cNvPr id="14" name="Rounded Rectangle 13"/>
           <p:cNvSpPr/>
           <p:nvPr/>
         </p:nvSpPr>
         <p:spPr>
           <a:xfrm>
-            <a:off x="5084064" y="3931920"/>
-            <a:ext cx="2057400" cy="2194560"/>
+            <a:off x="5084064" y="3794760"/>
+            <a:ext cx="2057400" cy="2331720"/>
           </a:xfrm>
           <a:prstGeom prst="roundRect">
             <a:avLst>
@@ -5515,13 +5550,13 @@
       </p:sp>
       <p:sp>
         <p:nvSpPr>
-          <p:cNvPr id="14" name="TextBox 13"/>
+          <p:cNvPr id="15" name="TextBox 14"/>
           <p:cNvSpPr txBox="1"/>
           <p:nvPr/>
         </p:nvSpPr>
         <p:spPr>
           <a:xfrm>
-            <a:off x="5175503" y="4069080"/>
+            <a:off x="5175503" y="3931920"/>
             <a:ext cx="1874519" cy="320040"/>
           </a:xfrm>
           <a:prstGeom prst="rect">
@@ -5550,13 +5585,13 @@
       </p:sp>
       <p:sp>
         <p:nvSpPr>
-          <p:cNvPr id="15" name="TextBox 14"/>
+          <p:cNvPr id="16" name="TextBox 15"/>
           <p:cNvSpPr txBox="1"/>
           <p:nvPr/>
         </p:nvSpPr>
         <p:spPr>
           <a:xfrm>
-            <a:off x="5175503" y="4434840"/>
+            <a:off x="5175503" y="4297680"/>
             <a:ext cx="1874519" cy="411480"/>
           </a:xfrm>
           <a:prstGeom prst="rect">
@@ -5585,14 +5620,14 @@
       </p:sp>
       <p:sp>
         <p:nvSpPr>
-          <p:cNvPr id="16" name="TextBox 15"/>
+          <p:cNvPr id="17" name="TextBox 16"/>
           <p:cNvSpPr txBox="1"/>
           <p:nvPr/>
         </p:nvSpPr>
         <p:spPr>
           <a:xfrm>
-            <a:off x="5175503" y="4937760"/>
-            <a:ext cx="1874519" cy="1005840"/>
+            <a:off x="5175503" y="4800600"/>
+            <a:ext cx="1874519" cy="1143000"/>
           </a:xfrm>
           <a:prstGeom prst="rect">
             <a:avLst/>
@@ -5621,14 +5656,14 @@
       </p:sp>
       <p:sp>
         <p:nvSpPr>
-          <p:cNvPr id="17" name="Rounded Rectangle 16"/>
+          <p:cNvPr id="18" name="Rounded Rectangle 17"/>
           <p:cNvSpPr/>
           <p:nvPr/>
         </p:nvSpPr>
         <p:spPr>
           <a:xfrm>
-            <a:off x="7260336" y="3931920"/>
-            <a:ext cx="2057400" cy="2194560"/>
+            <a:off x="7260336" y="3794760"/>
+            <a:ext cx="2057400" cy="2331720"/>
           </a:xfrm>
           <a:prstGeom prst="roundRect">
             <a:avLst>
@@ -5669,13 +5704,13 @@
       </p:sp>
       <p:sp>
         <p:nvSpPr>
-          <p:cNvPr id="18" name="TextBox 17"/>
+          <p:cNvPr id="19" name="TextBox 18"/>
           <p:cNvSpPr txBox="1"/>
           <p:nvPr/>
         </p:nvSpPr>
         <p:spPr>
           <a:xfrm>
-            <a:off x="7351775" y="4069080"/>
+            <a:off x="7351775" y="3931920"/>
             <a:ext cx="1874519" cy="320040"/>
           </a:xfrm>
           <a:prstGeom prst="rect">
@@ -5704,13 +5739,13 @@
       </p:sp>
       <p:sp>
         <p:nvSpPr>
-          <p:cNvPr id="19" name="TextBox 18"/>
+          <p:cNvPr id="20" name="TextBox 19"/>
           <p:cNvSpPr txBox="1"/>
           <p:nvPr/>
         </p:nvSpPr>
         <p:spPr>
           <a:xfrm>
-            <a:off x="7351775" y="4434840"/>
+            <a:off x="7351775" y="4297680"/>
             <a:ext cx="1874519" cy="411480"/>
           </a:xfrm>
           <a:prstGeom prst="rect">
@@ -5739,14 +5774,14 @@
       </p:sp>
       <p:sp>
         <p:nvSpPr>
-          <p:cNvPr id="20" name="TextBox 19"/>
+          <p:cNvPr id="21" name="TextBox 20"/>
           <p:cNvSpPr txBox="1"/>
           <p:nvPr/>
         </p:nvSpPr>
         <p:spPr>
           <a:xfrm>
-            <a:off x="7351775" y="4937760"/>
-            <a:ext cx="1874519" cy="1005840"/>
+            <a:off x="7351775" y="4800600"/>
+            <a:ext cx="1874519" cy="1143000"/>
           </a:xfrm>
           <a:prstGeom prst="rect">
             <a:avLst/>
@@ -5775,14 +5810,14 @@
       </p:sp>
       <p:sp>
         <p:nvSpPr>
-          <p:cNvPr id="21" name="Rounded Rectangle 20"/>
+          <p:cNvPr id="22" name="Rounded Rectangle 21"/>
           <p:cNvSpPr/>
           <p:nvPr/>
         </p:nvSpPr>
         <p:spPr>
           <a:xfrm>
-            <a:off x="9436608" y="3931920"/>
-            <a:ext cx="2057400" cy="2194560"/>
+            <a:off x="9436608" y="3794760"/>
+            <a:ext cx="2057400" cy="2331720"/>
           </a:xfrm>
           <a:prstGeom prst="roundRect">
             <a:avLst>
@@ -5823,13 +5858,13 @@
       </p:sp>
       <p:sp>
         <p:nvSpPr>
-          <p:cNvPr id="22" name="TextBox 21"/>
+          <p:cNvPr id="23" name="TextBox 22"/>
           <p:cNvSpPr txBox="1"/>
           <p:nvPr/>
         </p:nvSpPr>
         <p:spPr>
           <a:xfrm>
-            <a:off x="9528048" y="4069080"/>
+            <a:off x="9528048" y="3931920"/>
             <a:ext cx="1874519" cy="320040"/>
           </a:xfrm>
           <a:prstGeom prst="rect">
@@ -5858,13 +5893,13 @@
       </p:sp>
       <p:sp>
         <p:nvSpPr>
-          <p:cNvPr id="23" name="TextBox 22"/>
+          <p:cNvPr id="24" name="TextBox 23"/>
           <p:cNvSpPr txBox="1"/>
           <p:nvPr/>
         </p:nvSpPr>
         <p:spPr>
           <a:xfrm>
-            <a:off x="9528048" y="4434840"/>
+            <a:off x="9528048" y="4297680"/>
             <a:ext cx="1874519" cy="411480"/>
           </a:xfrm>
           <a:prstGeom prst="rect">
@@ -5893,14 +5928,14 @@
       </p:sp>
       <p:sp>
         <p:nvSpPr>
-          <p:cNvPr id="24" name="TextBox 23"/>
+          <p:cNvPr id="25" name="TextBox 24"/>
           <p:cNvSpPr txBox="1"/>
           <p:nvPr/>
         </p:nvSpPr>
         <p:spPr>
           <a:xfrm>
-            <a:off x="9528048" y="4937760"/>
-            <a:ext cx="1874519" cy="1005840"/>
+            <a:off x="9528048" y="4800600"/>
+            <a:ext cx="1874519" cy="1143000"/>
           </a:xfrm>
           <a:prstGeom prst="rect">
             <a:avLst/>

</xml_diff>